<commit_message>
Fix README formaat and update Presentation
</commit_message>
<xml_diff>
--- a/presentation/Three-Tier-Cloud-Architecture-Deployment.pptx
+++ b/presentation/Three-Tier-Cloud-Architecture-Deployment.pptx
@@ -16518,7 +16518,7 @@
         </p:spPr>
         <p:txBody>
           <a:bodyPr>
-            <a:normAutofit fontScale="85000" lnSpcReduction="10000"/>
+            <a:normAutofit lnSpcReduction="10000"/>
           </a:bodyPr>
           <a:lstStyle/>
           <a:p>
@@ -16535,15 +16535,6 @@
             <a:r>
               <a:rPr lang="en-US" dirty="0"/>
               <a:t>Replace the bastion host with AWS Systems Manager Session Manager</a:t>
-            </a:r>
-          </a:p>
-          <a:p>
-            <a:pPr marL="585216" lvl="1" indent="0">
-              <a:buNone/>
-            </a:pPr>
-            <a:r>
-              <a:rPr lang="en-US" dirty="0"/>
-              <a:t>Benefits: No inbound ports, no public IP, IAM-based access, smaller attack surface, no SSH key management</a:t>
             </a:r>
           </a:p>
           <a:p>
@@ -16815,7 +16806,7 @@
         </p:spPr>
         <p:txBody>
           <a:bodyPr vert="horz" lIns="91440" tIns="45720" rIns="91440" bIns="45720" rtlCol="0">
-            <a:normAutofit fontScale="92500" lnSpcReduction="20000"/>
+            <a:normAutofit fontScale="92500" lnSpcReduction="10000"/>
           </a:bodyPr>
           <a:lstStyle>
             <a:lvl1pPr marL="512064" indent="-512064" algn="l" defTabSz="914400" rtl="0" eaLnBrk="1" latinLnBrk="0" hangingPunct="1">
@@ -16998,18 +16989,13 @@
             </a:r>
           </a:p>
           <a:p>
-            <a:pPr marL="585216" lvl="1" indent="0">
-              <a:buNone/>
-            </a:pPr>
+            <a:r>
+              <a:rPr lang="en-US"/>
+              <a:t>Add </a:t>
+            </a:r>
             <a:r>
               <a:rPr lang="en-US" dirty="0"/>
-              <a:t>Benefits: Less NAT Gateway Traffic, Lower cost, private AWS Service access</a:t>
-            </a:r>
-          </a:p>
-          <a:p>
-            <a:r>
-              <a:rPr lang="en-US" dirty="0"/>
-              <a:t>Add Auto-scaling </a:t>
+              <a:t>Auto-scaling </a:t>
             </a:r>
             <a:r>
               <a:rPr lang="en-US" dirty="0" err="1"/>
@@ -20441,15 +20427,6 @@
 </file>
 
 <file path=customXml/item1.xml><?xml version="1.0" encoding="utf-8"?>
-<?mso-contentType ?>
-<FormTemplates xmlns="http://schemas.microsoft.com/sharepoint/v3/contenttype/forms">
-  <Display>DocumentLibraryForm</Display>
-  <Edit>DocumentLibraryForm</Edit>
-  <New>DocumentLibraryForm</New>
-</FormTemplates>
-</file>
-
-<file path=customXml/item2.xml><?xml version="1.0" encoding="utf-8"?>
 <p:properties xmlns:p="http://schemas.microsoft.com/office/2006/metadata/properties" xmlns:xsi="http://www.w3.org/2001/XMLSchema-instance" xmlns:pc="http://schemas.microsoft.com/office/infopath/2007/PartnerControls">
   <documentManagement>
     <_ip_UnifiedCompliancePolicyUIAction xmlns="http://schemas.microsoft.com/sharepoint/v3" xsi:nil="true"/>
@@ -20467,6 +20444,15 @@
     <MediaServiceKeyPoints xmlns="71af3243-3dd4-4a8d-8c0d-dd76da1f02a5" xsi:nil="true"/>
   </documentManagement>
 </p:properties>
+</file>
+
+<file path=customXml/item2.xml><?xml version="1.0" encoding="utf-8"?>
+<?mso-contentType ?>
+<FormTemplates xmlns="http://schemas.microsoft.com/sharepoint/v3/contenttype/forms">
+  <Display>DocumentLibraryForm</Display>
+  <Edit>DocumentLibraryForm</Edit>
+  <New>DocumentLibraryForm</New>
+</FormTemplates>
 </file>
 
 <file path=customXml/item3.xml><?xml version="1.0" encoding="utf-8"?>
@@ -20788,14 +20774,6 @@
 </file>
 
 <file path=customXml/itemProps1.xml><?xml version="1.0" encoding="utf-8"?>
-<ds:datastoreItem xmlns:ds="http://schemas.openxmlformats.org/officeDocument/2006/customXml" ds:itemID="{B0009351-EDD4-484E-ACD6-D50CCB137637}">
-  <ds:schemaRefs>
-    <ds:schemaRef ds:uri="http://schemas.microsoft.com/sharepoint/v3/contenttype/forms"/>
-  </ds:schemaRefs>
-</ds:datastoreItem>
-</file>
-
-<file path=customXml/itemProps2.xml><?xml version="1.0" encoding="utf-8"?>
 <ds:datastoreItem xmlns:ds="http://schemas.openxmlformats.org/officeDocument/2006/customXml" ds:itemID="{C8DB3C62-858A-4A01-AFEF-21E0BB8CE262}">
   <ds:schemaRefs>
     <ds:schemaRef ds:uri="http://schemas.microsoft.com/office/2006/metadata/properties"/>
@@ -20803,6 +20781,14 @@
     <ds:schemaRef ds:uri="http://schemas.microsoft.com/sharepoint/v3"/>
     <ds:schemaRef ds:uri="71af3243-3dd4-4a8d-8c0d-dd76da1f02a5"/>
     <ds:schemaRef ds:uri="230e9df3-be65-4c73-a93b-d1236ebd677e"/>
+  </ds:schemaRefs>
+</ds:datastoreItem>
+</file>
+
+<file path=customXml/itemProps2.xml><?xml version="1.0" encoding="utf-8"?>
+<ds:datastoreItem xmlns:ds="http://schemas.openxmlformats.org/officeDocument/2006/customXml" ds:itemID="{B0009351-EDD4-484E-ACD6-D50CCB137637}">
+  <ds:schemaRefs>
+    <ds:schemaRef ds:uri="http://schemas.microsoft.com/sharepoint/v3/contenttype/forms"/>
   </ds:schemaRefs>
 </ds:datastoreItem>
 </file>

</xml_diff>

<commit_message>
Fix typo in presentation
</commit_message>
<xml_diff>
--- a/presentation/Three-Tier-Cloud-Architecture-Deployment.pptx
+++ b/presentation/Three-Tier-Cloud-Architecture-Deployment.pptx
@@ -16990,20 +16990,24 @@
           </a:p>
           <a:p>
             <a:r>
-              <a:rPr lang="en-US"/>
+              <a:rPr lang="en-US" dirty="0"/>
               <a:t>Add </a:t>
             </a:r>
             <a:r>
-              <a:rPr lang="en-US" dirty="0"/>
+              <a:rPr lang="en-US"/>
               <a:t>Auto-scaling </a:t>
             </a:r>
             <a:r>
-              <a:rPr lang="en-US" dirty="0" err="1"/>
-              <a:t>por</a:t>
+              <a:rPr lang="en-US" dirty="0"/>
+              <a:t>f</a:t>
+            </a:r>
+            <a:r>
+              <a:rPr lang="en-US"/>
+              <a:t>or </a:t>
             </a:r>
             <a:r>
               <a:rPr lang="en-US" dirty="0"/>
-              <a:t> application tier</a:t>
+              <a:t>application tier</a:t>
             </a:r>
           </a:p>
           <a:p>
@@ -20427,6 +20431,15 @@
 </file>
 
 <file path=customXml/item1.xml><?xml version="1.0" encoding="utf-8"?>
+<?mso-contentType ?>
+<FormTemplates xmlns="http://schemas.microsoft.com/sharepoint/v3/contenttype/forms">
+  <Display>DocumentLibraryForm</Display>
+  <Edit>DocumentLibraryForm</Edit>
+  <New>DocumentLibraryForm</New>
+</FormTemplates>
+</file>
+
+<file path=customXml/item2.xml><?xml version="1.0" encoding="utf-8"?>
 <p:properties xmlns:p="http://schemas.microsoft.com/office/2006/metadata/properties" xmlns:xsi="http://www.w3.org/2001/XMLSchema-instance" xmlns:pc="http://schemas.microsoft.com/office/infopath/2007/PartnerControls">
   <documentManagement>
     <_ip_UnifiedCompliancePolicyUIAction xmlns="http://schemas.microsoft.com/sharepoint/v3" xsi:nil="true"/>
@@ -20444,15 +20457,6 @@
     <MediaServiceKeyPoints xmlns="71af3243-3dd4-4a8d-8c0d-dd76da1f02a5" xsi:nil="true"/>
   </documentManagement>
 </p:properties>
-</file>
-
-<file path=customXml/item2.xml><?xml version="1.0" encoding="utf-8"?>
-<?mso-contentType ?>
-<FormTemplates xmlns="http://schemas.microsoft.com/sharepoint/v3/contenttype/forms">
-  <Display>DocumentLibraryForm</Display>
-  <Edit>DocumentLibraryForm</Edit>
-  <New>DocumentLibraryForm</New>
-</FormTemplates>
 </file>
 
 <file path=customXml/item3.xml><?xml version="1.0" encoding="utf-8"?>
@@ -20774,6 +20778,14 @@
 </file>
 
 <file path=customXml/itemProps1.xml><?xml version="1.0" encoding="utf-8"?>
+<ds:datastoreItem xmlns:ds="http://schemas.openxmlformats.org/officeDocument/2006/customXml" ds:itemID="{B0009351-EDD4-484E-ACD6-D50CCB137637}">
+  <ds:schemaRefs>
+    <ds:schemaRef ds:uri="http://schemas.microsoft.com/sharepoint/v3/contenttype/forms"/>
+  </ds:schemaRefs>
+</ds:datastoreItem>
+</file>
+
+<file path=customXml/itemProps2.xml><?xml version="1.0" encoding="utf-8"?>
 <ds:datastoreItem xmlns:ds="http://schemas.openxmlformats.org/officeDocument/2006/customXml" ds:itemID="{C8DB3C62-858A-4A01-AFEF-21E0BB8CE262}">
   <ds:schemaRefs>
     <ds:schemaRef ds:uri="http://schemas.microsoft.com/office/2006/metadata/properties"/>
@@ -20781,14 +20793,6 @@
     <ds:schemaRef ds:uri="http://schemas.microsoft.com/sharepoint/v3"/>
     <ds:schemaRef ds:uri="71af3243-3dd4-4a8d-8c0d-dd76da1f02a5"/>
     <ds:schemaRef ds:uri="230e9df3-be65-4c73-a93b-d1236ebd677e"/>
-  </ds:schemaRefs>
-</ds:datastoreItem>
-</file>
-
-<file path=customXml/itemProps2.xml><?xml version="1.0" encoding="utf-8"?>
-<ds:datastoreItem xmlns:ds="http://schemas.openxmlformats.org/officeDocument/2006/customXml" ds:itemID="{B0009351-EDD4-484E-ACD6-D50CCB137637}">
-  <ds:schemaRefs>
-    <ds:schemaRef ds:uri="http://schemas.microsoft.com/sharepoint/v3/contenttype/forms"/>
   </ds:schemaRefs>
 </ds:datastoreItem>
 </file>

</xml_diff>